<commit_message>
slides: add GitHub-viewable PDF export (matplotlib backend)
Rebuild make_slides.py around one content spec with two backends: the editable
petsc_multiagent_tokamak.pptx and a faithful 10-page petsc_multiagent_tokamak.pdf
rendered with matplotlib (no LibreOffice needed), so the deck renders inline on
GitHub without downloading. Verified pages via pdftoppm (title, figure, and
convergence slides); fixed title-line fit, text/figure spacing, and footer/caption
overlap.

Co-Authored-By: Claude Opus 4.8 (1M context) <noreply@anthropic.com>
</commit_message>
<xml_diff>
--- a/slides/petsc_multiagent_tokamak.pptx
+++ b/slides/petsc_multiagent_tokamak.pptx
@@ -3099,14 +3099,58 @@
       <p:grpSpPr/>
       <p:sp>
         <p:nvSpPr>
-          <p:cNvPr id="2" name="TextBox 1"/>
+          <p:cNvPr id="2" name="Rectangle 1"/>
+          <p:cNvSpPr/>
+          <p:nvPr/>
+        </p:nvSpPr>
+        <p:spPr>
+          <a:xfrm>
+            <a:off x="0" y="0"/>
+            <a:ext cx="12191695" cy="6858000"/>
+          </a:xfrm>
+          <a:prstGeom prst="rect">
+            <a:avLst/>
+          </a:prstGeom>
+          <a:solidFill>
+            <a:srgbClr val="002B5C"/>
+          </a:solidFill>
+          <a:ln>
+            <a:noFill/>
+          </a:ln>
+          <a:effectLst/>
+        </p:spPr>
+        <p:style>
+          <a:lnRef idx="1">
+            <a:schemeClr val="accent1"/>
+          </a:lnRef>
+          <a:fillRef idx="3">
+            <a:schemeClr val="accent1"/>
+          </a:fillRef>
+          <a:effectRef idx="2">
+            <a:schemeClr val="accent1"/>
+          </a:effectRef>
+          <a:fontRef idx="minor">
+            <a:schemeClr val="lt1"/>
+          </a:fontRef>
+        </p:style>
+        <p:txBody>
+          <a:bodyPr rtlCol="0" anchor="ctr"/>
+          <a:lstStyle/>
+          <a:p>
+            <a:pPr algn="ctr"/>
+          </a:p>
+        </p:txBody>
+      </p:sp>
+      <p:sp>
+        <p:nvSpPr>
+          <p:cNvPr id="3" name="TextBox 2"/>
           <p:cNvSpPr txBox="1"/>
           <p:nvPr/>
         </p:nvSpPr>
         <p:spPr>
           <a:xfrm>
-            <a:off x="640080" y="2011680"/>
-            <a:ext cx="10972800" cy="2286000"/>
+            <a:off x="731520" y="2011680"/>
+            <a:ext cx="10728655" cy="2743200"/>
           </a:xfrm>
           <a:prstGeom prst="rect">
             <a:avLst/>
@@ -3119,34 +3163,55 @@
           </a:bodyPr>
           <a:lstStyle/>
           <a:p>
-            <a:r>
-              <a:rPr sz="3800" b="1">
-                <a:solidFill>
-                  <a:srgbClr val="002B5C"/>
-                </a:solidFill>
-              </a:rPr>
-              <a:t>Automated Problem-to-Solution Generation for a
-Tokamak Fusion-Plasma Simulation</a:t>
-            </a:r>
-          </a:p>
-          <a:p>
+            <a:pPr algn="ctr"/>
+            <a:r>
+              <a:rPr sz="3300" b="1">
+                <a:solidFill>
+                  <a:srgbClr val="FFFFFF"/>
+                </a:solidFill>
+              </a:rPr>
+              <a:t>Automated Problem-to-Solution Generation</a:t>
+            </a:r>
+          </a:p>
+          <a:p>
+            <a:pPr algn="ctr"/>
+            <a:r>
+              <a:rPr sz="3300" b="1">
+                <a:solidFill>
+                  <a:srgbClr val="FFFFFF"/>
+                </a:solidFill>
+              </a:rPr>
+              <a:t>for a Tokamak Fusion-Plasma Simulation</a:t>
+            </a:r>
+          </a:p>
+          <a:p>
+            <a:pPr algn="ctr">
+              <a:spcBef>
+                <a:spcPts val="1000"/>
+              </a:spcBef>
+            </a:pPr>
             <a:r>
               <a:rPr sz="2200">
                 <a:solidFill>
-                  <a:srgbClr val="007D8A"/>
+                  <a:srgbClr val="7FD3DC"/>
                 </a:solidFill>
               </a:rPr>
               <a:t>A hierarchical multi-agent PETSc system, applied and verified</a:t>
             </a:r>
           </a:p>
           <a:p>
+            <a:pPr algn="ctr">
+              <a:spcBef>
+                <a:spcPts val="1000"/>
+              </a:spcBef>
+            </a:pPr>
             <a:r>
               <a:rPr sz="1600">
                 <a:solidFill>
-                  <a:srgbClr val="555555"/>
-                </a:solidFill>
-              </a:rPr>
-              <a:t>Argonne National Laboratory — summer 2026 intern event</a:t>
+                  <a:srgbClr val="CFE0EA"/>
+                </a:solidFill>
+              </a:rPr>
+              <a:t>Argonne National Laboratory - summer 2026 intern event</a:t>
             </a:r>
           </a:p>
         </p:txBody>
@@ -3178,7 +3243,7 @@
         <p:spPr>
           <a:xfrm>
             <a:off x="457200" y="274320"/>
-            <a:ext cx="11274552" cy="914400"/>
+            <a:ext cx="11277295" cy="914400"/>
           </a:xfrm>
           <a:prstGeom prst="rect">
             <a:avLst/>
@@ -3192,7 +3257,7 @@
           <a:lstStyle/>
           <a:p>
             <a:r>
-              <a:rPr sz="3000" b="1">
+              <a:rPr sz="2800" b="1">
                 <a:solidFill>
                   <a:srgbClr val="002B5C"/>
                 </a:solidFill>
@@ -3204,14 +3269,58 @@
       </p:sp>
       <p:sp>
         <p:nvSpPr>
-          <p:cNvPr id="3" name="TextBox 2"/>
+          <p:cNvPr id="3" name="Rectangle 2"/>
+          <p:cNvSpPr/>
+          <p:nvPr/>
+        </p:nvSpPr>
+        <p:spPr>
+          <a:xfrm>
+            <a:off x="457200" y="1188720"/>
+            <a:ext cx="11277295" cy="54864"/>
+          </a:xfrm>
+          <a:prstGeom prst="rect">
+            <a:avLst/>
+          </a:prstGeom>
+          <a:solidFill>
+            <a:srgbClr val="007D8A"/>
+          </a:solidFill>
+          <a:ln>
+            <a:noFill/>
+          </a:ln>
+          <a:effectLst/>
+        </p:spPr>
+        <p:style>
+          <a:lnRef idx="1">
+            <a:schemeClr val="accent1"/>
+          </a:lnRef>
+          <a:fillRef idx="3">
+            <a:schemeClr val="accent1"/>
+          </a:fillRef>
+          <a:effectRef idx="2">
+            <a:schemeClr val="accent1"/>
+          </a:effectRef>
+          <a:fontRef idx="minor">
+            <a:schemeClr val="lt1"/>
+          </a:fontRef>
+        </p:style>
+        <p:txBody>
+          <a:bodyPr rtlCol="0" anchor="ctr"/>
+          <a:lstStyle/>
+          <a:p>
+            <a:pPr algn="ctr"/>
+          </a:p>
+        </p:txBody>
+      </p:sp>
+      <p:sp>
+        <p:nvSpPr>
+          <p:cNvPr id="4" name="TextBox 3"/>
           <p:cNvSpPr txBox="1"/>
           <p:nvPr/>
         </p:nvSpPr>
         <p:spPr>
           <a:xfrm>
-            <a:off x="640080" y="1371600"/>
-            <a:ext cx="6583680" cy="4937760"/>
+            <a:off x="548640" y="1463040"/>
+            <a:ext cx="10911535" cy="5029200"/>
           </a:xfrm>
           <a:prstGeom prst="rect">
             <a:avLst/>
@@ -3230,12 +3339,12 @@
               </a:spcAft>
             </a:pPr>
             <a:r>
-              <a:rPr sz="1800">
-                <a:solidFill>
-                  <a:srgbClr val="222222"/>
-                </a:solidFill>
-              </a:rPr>
-              <a:t>A multi-agent system generated a correct, verified PETSc fusion-MHD solver from a prompt.</a:t>
+              <a:rPr sz="2000">
+                <a:solidFill>
+                  <a:srgbClr val="1F1F1F"/>
+                </a:solidFill>
+              </a:rPr>
+              <a:t>• A multi-agent system generated a correct, verified PETSc fusion-MHD solver from a prompt.</a:t>
             </a:r>
           </a:p>
           <a:p>
@@ -3245,12 +3354,12 @@
               </a:spcAft>
             </a:pPr>
             <a:r>
-              <a:rPr sz="1800">
-                <a:solidFill>
-                  <a:srgbClr val="222222"/>
-                </a:solidFill>
-              </a:rPr>
-              <a:t>Verification-driven: convergence + exact-solution checks, not just plausible output.</a:t>
+              <a:rPr sz="2000">
+                <a:solidFill>
+                  <a:srgbClr val="1F1F1F"/>
+                </a:solidFill>
+              </a:rPr>
+              <a:t>• Verification-driven: convergence + exact-solution checks, not just plausible output.</a:t>
             </a:r>
           </a:p>
           <a:p>
@@ -3260,12 +3369,12 @@
               </a:spcAft>
             </a:pPr>
             <a:r>
-              <a:rPr sz="1800">
-                <a:solidFill>
-                  <a:srgbClr val="222222"/>
-                </a:solidFill>
-              </a:rPr>
-              <a:t>Next: shaped real-machine equilibria (Solov’ev/Cerfon–Freidberg), q-profile, GPU scale-up.</a:t>
+              <a:rPr sz="2000">
+                <a:solidFill>
+                  <a:srgbClr val="1F1F1F"/>
+                </a:solidFill>
+              </a:rPr>
+              <a:t>• Next: shaped real-machine equilibria (Solov'ev/Cerfon-Freidberg), q-profile, GPU scale-up.</a:t>
             </a:r>
           </a:p>
           <a:p>
@@ -3275,12 +3384,12 @@
               </a:spcAft>
             </a:pPr>
             <a:r>
-              <a:rPr sz="1800">
-                <a:solidFill>
-                  <a:srgbClr val="222222"/>
-                </a:solidFill>
-              </a:rPr>
-              <a:t>Next: demonstrate the fully-autonomous built-in orchestrator agent end to end.</a:t>
+              <a:rPr sz="2000">
+                <a:solidFill>
+                  <a:srgbClr val="1F1F1F"/>
+                </a:solidFill>
+              </a:rPr>
+              <a:t>• Next: demonstrate the fully-autonomous built-in orchestrator agent end to end.</a:t>
             </a:r>
           </a:p>
           <a:p>
@@ -3290,12 +3399,12 @@
               </a:spcAft>
             </a:pPr>
             <a:r>
-              <a:rPr sz="1800">
-                <a:solidFill>
-                  <a:srgbClr val="222222"/>
-                </a:solidFill>
-              </a:rPr>
-              <a:t>Code + docs: github.com/engineer-scientist/petsc_mcp_servers_tokamak</a:t>
+              <a:rPr sz="2000">
+                <a:solidFill>
+                  <a:srgbClr val="1F1F1F"/>
+                </a:solidFill>
+              </a:rPr>
+              <a:t>• Code + docs: github.com/engineer-scientist/petsc_mcp_servers_tokamak</a:t>
             </a:r>
           </a:p>
         </p:txBody>
@@ -3327,7 +3436,7 @@
         <p:spPr>
           <a:xfrm>
             <a:off x="457200" y="274320"/>
-            <a:ext cx="11274552" cy="914400"/>
+            <a:ext cx="11277295" cy="914400"/>
           </a:xfrm>
           <a:prstGeom prst="rect">
             <a:avLst/>
@@ -3341,7 +3450,7 @@
           <a:lstStyle/>
           <a:p>
             <a:r>
-              <a:rPr sz="3000" b="1">
+              <a:rPr sz="2800" b="1">
                 <a:solidFill>
                   <a:srgbClr val="002B5C"/>
                 </a:solidFill>
@@ -3353,14 +3462,58 @@
       </p:sp>
       <p:sp>
         <p:nvSpPr>
-          <p:cNvPr id="3" name="TextBox 2"/>
+          <p:cNvPr id="3" name="Rectangle 2"/>
+          <p:cNvSpPr/>
+          <p:nvPr/>
+        </p:nvSpPr>
+        <p:spPr>
+          <a:xfrm>
+            <a:off x="457200" y="1188720"/>
+            <a:ext cx="11277295" cy="54864"/>
+          </a:xfrm>
+          <a:prstGeom prst="rect">
+            <a:avLst/>
+          </a:prstGeom>
+          <a:solidFill>
+            <a:srgbClr val="007D8A"/>
+          </a:solidFill>
+          <a:ln>
+            <a:noFill/>
+          </a:ln>
+          <a:effectLst/>
+        </p:spPr>
+        <p:style>
+          <a:lnRef idx="1">
+            <a:schemeClr val="accent1"/>
+          </a:lnRef>
+          <a:fillRef idx="3">
+            <a:schemeClr val="accent1"/>
+          </a:fillRef>
+          <a:effectRef idx="2">
+            <a:schemeClr val="accent1"/>
+          </a:effectRef>
+          <a:fontRef idx="minor">
+            <a:schemeClr val="lt1"/>
+          </a:fontRef>
+        </p:style>
+        <p:txBody>
+          <a:bodyPr rtlCol="0" anchor="ctr"/>
+          <a:lstStyle/>
+          <a:p>
+            <a:pPr algn="ctr"/>
+          </a:p>
+        </p:txBody>
+      </p:sp>
+      <p:sp>
+        <p:nvSpPr>
+          <p:cNvPr id="4" name="TextBox 3"/>
           <p:cNvSpPr txBox="1"/>
           <p:nvPr/>
         </p:nvSpPr>
         <p:spPr>
           <a:xfrm>
-            <a:off x="640080" y="1371600"/>
-            <a:ext cx="6583680" cy="4937760"/>
+            <a:off x="548640" y="1463040"/>
+            <a:ext cx="10911535" cy="5029200"/>
           </a:xfrm>
           <a:prstGeom prst="rect">
             <a:avLst/>
@@ -3379,12 +3532,12 @@
               </a:spcAft>
             </a:pPr>
             <a:r>
-              <a:rPr sz="1800">
-                <a:solidFill>
-                  <a:srgbClr val="222222"/>
-                </a:solidFill>
-              </a:rPr>
-              <a:t>A tokamak confines a ~100-million-°C plasma in a magnetic “cage” so nuclei fuse.</a:t>
+              <a:rPr sz="2000">
+                <a:solidFill>
+                  <a:srgbClr val="1F1F1F"/>
+                </a:solidFill>
+              </a:rPr>
+              <a:t>• A tokamak confines a ~100-million-C plasma in a magnetic “cage” so nuclei fuse.</a:t>
             </a:r>
           </a:p>
           <a:p>
@@ -3394,12 +3547,12 @@
               </a:spcAft>
             </a:pPr>
             <a:r>
-              <a:rPr sz="1800">
-                <a:solidFill>
-                  <a:srgbClr val="222222"/>
-                </a:solidFill>
-              </a:rPr>
-              <a:t>Simulation predicts — before building hardware — whether the plasma stays confined.</a:t>
+              <a:rPr sz="2000">
+                <a:solidFill>
+                  <a:srgbClr val="1F1F1F"/>
+                </a:solidFill>
+              </a:rPr>
+              <a:t>• Simulation predicts - before building hardware - whether the plasma stays confined.</a:t>
             </a:r>
           </a:p>
           <a:p>
@@ -3409,12 +3562,12 @@
               </a:spcAft>
             </a:pPr>
             <a:r>
-              <a:rPr sz="1800">
-                <a:solidFill>
-                  <a:srgbClr val="222222"/>
-                </a:solidFill>
-              </a:rPr>
-              <a:t>But turning a scientific idea into correct, fast HPC code needs scarce, implicit expertise:</a:t>
+              <a:rPr sz="2000">
+                <a:solidFill>
+                  <a:srgbClr val="1F1F1F"/>
+                </a:solidFill>
+              </a:rPr>
+              <a:t>• But turning a scientific idea into correct, fast HPC code needs scarce, implicit expertise:</a:t>
             </a:r>
           </a:p>
           <a:p>
@@ -3424,12 +3577,12 @@
               </a:spcAft>
             </a:pPr>
             <a:r>
-              <a:rPr sz="1500">
-                <a:solidFill>
-                  <a:srgbClr val="555555"/>
-                </a:solidFill>
-              </a:rPr>
-              <a:t>numerical methods (grids, discretizations, solvers)</a:t>
+              <a:rPr sz="1700">
+                <a:solidFill>
+                  <a:srgbClr val="4A4A4A"/>
+                </a:solidFill>
+              </a:rPr>
+              <a:t>– numerical methods (grids, discretizations, solvers)</a:t>
             </a:r>
           </a:p>
           <a:p>
@@ -3439,12 +3592,12 @@
               </a:spcAft>
             </a:pPr>
             <a:r>
-              <a:rPr sz="1500">
-                <a:solidFill>
-                  <a:srgbClr val="555555"/>
-                </a:solidFill>
-              </a:rPr>
-              <a:t>library APIs and parallelism (here: PETSc on many cores/GPUs)</a:t>
+              <a:rPr sz="1700">
+                <a:solidFill>
+                  <a:srgbClr val="4A4A4A"/>
+                </a:solidFill>
+              </a:rPr>
+              <a:t>– library APIs and parallelism (here: PETSc on many cores/GPUs)</a:t>
             </a:r>
           </a:p>
           <a:p>
@@ -3454,12 +3607,12 @@
               </a:spcAft>
             </a:pPr>
             <a:r>
-              <a:rPr sz="1500">
-                <a:solidFill>
-                  <a:srgbClr val="555555"/>
-                </a:solidFill>
-              </a:rPr>
-              <a:t>verification: is the answer actually right?</a:t>
+              <a:rPr sz="1700">
+                <a:solidFill>
+                  <a:srgbClr val="4A4A4A"/>
+                </a:solidFill>
+              </a:rPr>
+              <a:t>– verification: is the answer actually right?</a:t>
             </a:r>
           </a:p>
           <a:p>
@@ -3469,12 +3622,12 @@
               </a:spcAft>
             </a:pPr>
             <a:r>
-              <a:rPr sz="1800">
-                <a:solidFill>
-                  <a:srgbClr val="222222"/>
-                </a:solidFill>
-              </a:rPr>
-              <a:t>Question: can a multi-agent AI system automate this path — and can we trust the result?</a:t>
+              <a:rPr sz="2000">
+                <a:solidFill>
+                  <a:srgbClr val="1F1F1F"/>
+                </a:solidFill>
+              </a:rPr>
+              <a:t>• Question: can a multi-agent AI system automate this path - and can we trust the result?</a:t>
             </a:r>
           </a:p>
         </p:txBody>
@@ -3506,7 +3659,7 @@
         <p:spPr>
           <a:xfrm>
             <a:off x="457200" y="274320"/>
-            <a:ext cx="11274552" cy="914400"/>
+            <a:ext cx="11277295" cy="914400"/>
           </a:xfrm>
           <a:prstGeom prst="rect">
             <a:avLst/>
@@ -3520,26 +3673,70 @@
           <a:lstStyle/>
           <a:p>
             <a:r>
-              <a:rPr sz="3000" b="1">
+              <a:rPr sz="2800" b="1">
                 <a:solidFill>
                   <a:srgbClr val="002B5C"/>
                 </a:solidFill>
               </a:rPr>
-              <a:t>The problem: tokamak Grad–Shafranov equilibrium</a:t>
-            </a:r>
-          </a:p>
-        </p:txBody>
-      </p:sp>
-      <p:sp>
-        <p:nvSpPr>
-          <p:cNvPr id="3" name="TextBox 2"/>
+              <a:t>The problem: tokamak Grad-Shafranov equilibrium</a:t>
+            </a:r>
+          </a:p>
+        </p:txBody>
+      </p:sp>
+      <p:sp>
+        <p:nvSpPr>
+          <p:cNvPr id="3" name="Rectangle 2"/>
+          <p:cNvSpPr/>
+          <p:nvPr/>
+        </p:nvSpPr>
+        <p:spPr>
+          <a:xfrm>
+            <a:off x="457200" y="1188720"/>
+            <a:ext cx="11277295" cy="54864"/>
+          </a:xfrm>
+          <a:prstGeom prst="rect">
+            <a:avLst/>
+          </a:prstGeom>
+          <a:solidFill>
+            <a:srgbClr val="007D8A"/>
+          </a:solidFill>
+          <a:ln>
+            <a:noFill/>
+          </a:ln>
+          <a:effectLst/>
+        </p:spPr>
+        <p:style>
+          <a:lnRef idx="1">
+            <a:schemeClr val="accent1"/>
+          </a:lnRef>
+          <a:fillRef idx="3">
+            <a:schemeClr val="accent1"/>
+          </a:fillRef>
+          <a:effectRef idx="2">
+            <a:schemeClr val="accent1"/>
+          </a:effectRef>
+          <a:fontRef idx="minor">
+            <a:schemeClr val="lt1"/>
+          </a:fontRef>
+        </p:style>
+        <p:txBody>
+          <a:bodyPr rtlCol="0" anchor="ctr"/>
+          <a:lstStyle/>
+          <a:p>
+            <a:pPr algn="ctr"/>
+          </a:p>
+        </p:txBody>
+      </p:sp>
+      <p:sp>
+        <p:nvSpPr>
+          <p:cNvPr id="4" name="TextBox 3"/>
           <p:cNvSpPr txBox="1"/>
           <p:nvPr/>
         </p:nvSpPr>
         <p:spPr>
           <a:xfrm>
-            <a:off x="640080" y="1371600"/>
-            <a:ext cx="6400800" cy="4937760"/>
+            <a:off x="548640" y="1463040"/>
+            <a:ext cx="5852160" cy="5029200"/>
           </a:xfrm>
           <a:prstGeom prst="rect">
             <a:avLst/>
@@ -3558,12 +3755,12 @@
               </a:spcAft>
             </a:pPr>
             <a:r>
-              <a:rPr sz="1800">
-                <a:solidFill>
-                  <a:srgbClr val="222222"/>
-                </a:solidFill>
-              </a:rPr>
-              <a:t>The axisymmetric ideal-MHD force balance for the poloidal flux ψ(R,Z):</a:t>
+              <a:rPr sz="2000">
+                <a:solidFill>
+                  <a:srgbClr val="1F1F1F"/>
+                </a:solidFill>
+              </a:rPr>
+              <a:t>• Axisymmetric ideal-MHD force balance for the poloidal flux psi(R,Z):</a:t>
             </a:r>
           </a:p>
           <a:p>
@@ -3573,12 +3770,12 @@
               </a:spcAft>
             </a:pPr>
             <a:r>
-              <a:rPr sz="1500">
-                <a:solidFill>
-                  <a:srgbClr val="555555"/>
-                </a:solidFill>
-              </a:rPr>
-              <a:t>Δ* ψ = -μ₀ R² p′(ψ) - F F′(ψ)</a:t>
+              <a:rPr sz="1700">
+                <a:solidFill>
+                  <a:srgbClr val="4A4A4A"/>
+                </a:solidFill>
+              </a:rPr>
+              <a:t>– Δ* psi = -μ₀ R² p'(psi) - F F'(psi)</a:t>
             </a:r>
           </a:p>
           <a:p>
@@ -3588,12 +3785,12 @@
               </a:spcAft>
             </a:pPr>
             <a:r>
-              <a:rPr sz="1800">
-                <a:solidFill>
-                  <a:srgbClr val="222222"/>
-                </a:solidFill>
-              </a:rPr>
-              <a:t>Its solution gives the flux surfaces, magnetic axis, and safety factor q.</a:t>
+              <a:rPr sz="2000">
+                <a:solidFill>
+                  <a:srgbClr val="1F1F1F"/>
+                </a:solidFill>
+              </a:rPr>
+              <a:t>• Its solution gives the flux surfaces, magnetic axis, and safety factor q.</a:t>
             </a:r>
           </a:p>
           <a:p>
@@ -3603,12 +3800,12 @@
               </a:spcAft>
             </a:pPr>
             <a:r>
-              <a:rPr sz="1800">
-                <a:solidFill>
-                  <a:srgbClr val="222222"/>
-                </a:solidFill>
-              </a:rPr>
-              <a:t>Elliptic, nonlinear, time-independent → a natural PETSc SNES problem.</a:t>
+              <a:rPr sz="2000">
+                <a:solidFill>
+                  <a:srgbClr val="1F1F1F"/>
+                </a:solidFill>
+              </a:rPr>
+              <a:t>• Elliptic, nonlinear, time-independent → a natural PETSc SNES problem.</a:t>
             </a:r>
           </a:p>
           <a:p>
@@ -3618,19 +3815,19 @@
               </a:spcAft>
             </a:pPr>
             <a:r>
-              <a:rPr sz="1800">
-                <a:solidFill>
-                  <a:srgbClr val="222222"/>
-                </a:solidFill>
-              </a:rPr>
-              <a:t>Verifiable: a manufactured exact solution gives a rigorous convergence test.</a:t>
+              <a:rPr sz="2000">
+                <a:solidFill>
+                  <a:srgbClr val="1F1F1F"/>
+                </a:solidFill>
+              </a:rPr>
+              <a:t>• Verifiable: a manufactured exact solution gives a rigorous convergence test.</a:t>
             </a:r>
           </a:p>
         </p:txBody>
       </p:sp>
       <p:pic>
         <p:nvPicPr>
-          <p:cNvPr id="4" name="Picture 3" descr="gs_flux_surfaces.png"/>
+          <p:cNvPr id="5" name="Picture 4" descr="gs_flux_surfaces.png"/>
           <p:cNvPicPr>
             <a:picLocks noChangeAspect="1"/>
           </p:cNvPicPr>
@@ -3644,14 +3841,48 @@
         </p:blipFill>
         <p:spPr>
           <a:xfrm>
-            <a:off x="7315200" y="1371600"/>
-            <a:ext cx="4075611" cy="4754880"/>
+            <a:off x="7558887" y="1554480"/>
+            <a:ext cx="3840479" cy="4480559"/>
           </a:xfrm>
           <a:prstGeom prst="rect">
             <a:avLst/>
           </a:prstGeom>
         </p:spPr>
       </p:pic>
+      <p:sp>
+        <p:nvSpPr>
+          <p:cNvPr id="6" name="TextBox 5"/>
+          <p:cNvSpPr txBox="1"/>
+          <p:nvPr/>
+        </p:nvSpPr>
+        <p:spPr>
+          <a:xfrm>
+            <a:off x="7223760" y="6080759"/>
+            <a:ext cx="4510735" cy="457200"/>
+          </a:xfrm>
+          <a:prstGeom prst="rect">
+            <a:avLst/>
+          </a:prstGeom>
+          <a:noFill/>
+        </p:spPr>
+        <p:txBody>
+          <a:bodyPr wrap="none">
+            <a:spAutoFit/>
+          </a:bodyPr>
+          <a:lstStyle/>
+          <a:p>
+            <a:pPr algn="ctr"/>
+            <a:r>
+              <a:rPr sz="1300">
+                <a:solidFill>
+                  <a:srgbClr val="4A4A4A"/>
+                </a:solidFill>
+              </a:rPr>
+              <a:t>Flux surfaces of the verified solution</a:t>
+            </a:r>
+          </a:p>
+        </p:txBody>
+      </p:sp>
     </p:spTree>
   </p:cSld>
   <p:clrMapOvr>
@@ -3679,7 +3910,7 @@
         <p:spPr>
           <a:xfrm>
             <a:off x="457200" y="274320"/>
-            <a:ext cx="11274552" cy="914400"/>
+            <a:ext cx="11277295" cy="914400"/>
           </a:xfrm>
           <a:prstGeom prst="rect">
             <a:avLst/>
@@ -3693,7 +3924,7 @@
           <a:lstStyle/>
           <a:p>
             <a:r>
-              <a:rPr sz="3000" b="1">
+              <a:rPr sz="2800" b="1">
                 <a:solidFill>
                   <a:srgbClr val="002B5C"/>
                 </a:solidFill>
@@ -3705,14 +3936,58 @@
       </p:sp>
       <p:sp>
         <p:nvSpPr>
-          <p:cNvPr id="3" name="TextBox 2"/>
+          <p:cNvPr id="3" name="Rectangle 2"/>
+          <p:cNvSpPr/>
+          <p:nvPr/>
+        </p:nvSpPr>
+        <p:spPr>
+          <a:xfrm>
+            <a:off x="457200" y="1188720"/>
+            <a:ext cx="11277295" cy="54864"/>
+          </a:xfrm>
+          <a:prstGeom prst="rect">
+            <a:avLst/>
+          </a:prstGeom>
+          <a:solidFill>
+            <a:srgbClr val="007D8A"/>
+          </a:solidFill>
+          <a:ln>
+            <a:noFill/>
+          </a:ln>
+          <a:effectLst/>
+        </p:spPr>
+        <p:style>
+          <a:lnRef idx="1">
+            <a:schemeClr val="accent1"/>
+          </a:lnRef>
+          <a:fillRef idx="3">
+            <a:schemeClr val="accent1"/>
+          </a:fillRef>
+          <a:effectRef idx="2">
+            <a:schemeClr val="accent1"/>
+          </a:effectRef>
+          <a:fontRef idx="minor">
+            <a:schemeClr val="lt1"/>
+          </a:fontRef>
+        </p:style>
+        <p:txBody>
+          <a:bodyPr rtlCol="0" anchor="ctr"/>
+          <a:lstStyle/>
+          <a:p>
+            <a:pPr algn="ctr"/>
+          </a:p>
+        </p:txBody>
+      </p:sp>
+      <p:sp>
+        <p:nvSpPr>
+          <p:cNvPr id="4" name="TextBox 3"/>
           <p:cNvSpPr txBox="1"/>
           <p:nvPr/>
         </p:nvSpPr>
         <p:spPr>
           <a:xfrm>
-            <a:off x="640080" y="1371600"/>
-            <a:ext cx="6583680" cy="4937760"/>
+            <a:off x="548640" y="1463040"/>
+            <a:ext cx="10911535" cy="5029200"/>
           </a:xfrm>
           <a:prstGeom prst="rect">
             <a:avLst/>
@@ -3731,12 +4006,12 @@
               </a:spcAft>
             </a:pPr>
             <a:r>
-              <a:rPr sz="1800">
-                <a:solidFill>
-                  <a:srgbClr val="222222"/>
-                </a:solidFill>
-              </a:rPr>
-              <a:t>Problem Definition — Mathematical Modeling agent → strong/weak form, name, time-dep.</a:t>
+              <a:rPr sz="2000">
+                <a:solidFill>
+                  <a:srgbClr val="1F1F1F"/>
+                </a:solidFill>
+              </a:rPr>
+              <a:t>• Problem Definition - Mathematical Modeling agent → strong/weak form, name, time-dep.</a:t>
             </a:r>
           </a:p>
           <a:p>
@@ -3746,12 +4021,12 @@
               </a:spcAft>
             </a:pPr>
             <a:r>
-              <a:rPr sz="1800">
-                <a:solidFill>
-                  <a:srgbClr val="222222"/>
-                </a:solidFill>
-              </a:rPr>
-              <a:t>Agent Execution — Numerical Analysis agent → grid, discretization, solver (SNES).</a:t>
+              <a:rPr sz="2000">
+                <a:solidFill>
+                  <a:srgbClr val="1F1F1F"/>
+                </a:solidFill>
+              </a:rPr>
+              <a:t>• Agent Execution - Numerical Analysis agent → grid, discretization, solver (SNES).</a:t>
             </a:r>
           </a:p>
           <a:p>
@@ -3761,12 +4036,12 @@
               </a:spcAft>
             </a:pPr>
             <a:r>
-              <a:rPr sz="1800">
-                <a:solidFill>
-                  <a:srgbClr val="222222"/>
-                </a:solidFill>
-              </a:rPr>
-              <a:t>Agent Execution — HPC Code Generation agent → writes, compiles &amp; runs PETSc C.</a:t>
+              <a:rPr sz="2000">
+                <a:solidFill>
+                  <a:srgbClr val="1F1F1F"/>
+                </a:solidFill>
+              </a:rPr>
+              <a:t>• Agent Execution - HPC Code Generation agent → writes, compiles &amp; runs PETSc C.</a:t>
             </a:r>
           </a:p>
           <a:p>
@@ -3776,12 +4051,12 @@
               </a:spcAft>
             </a:pPr>
             <a:r>
-              <a:rPr sz="1800">
-                <a:solidFill>
-                  <a:srgbClr val="222222"/>
-                </a:solidFill>
-              </a:rPr>
-              <a:t>Execution substrate — compile-run agent (make / run on the real machine).</a:t>
+              <a:rPr sz="2000">
+                <a:solidFill>
+                  <a:srgbClr val="1F1F1F"/>
+                </a:solidFill>
+              </a:rPr>
+              <a:t>• Execution substrate - compile-run agent (make / run on the real machine).</a:t>
             </a:r>
           </a:p>
           <a:p>
@@ -3791,12 +4066,12 @@
               </a:spcAft>
             </a:pPr>
             <a:r>
-              <a:rPr sz="1800">
-                <a:solidFill>
-                  <a:srgbClr val="222222"/>
-                </a:solidFill>
-              </a:rPr>
-              <a:t>All agents run against Argonne's Argo gateway (Claude Opus 4.8).</a:t>
+              <a:rPr sz="2000">
+                <a:solidFill>
+                  <a:srgbClr val="1F1F1F"/>
+                </a:solidFill>
+              </a:rPr>
+              <a:t>• All agents run against Argonne's Argo gateway (Claude Opus 4.8).</a:t>
             </a:r>
           </a:p>
           <a:p>
@@ -3806,12 +4081,12 @@
               </a:spcAft>
             </a:pPr>
             <a:r>
-              <a:rPr sz="1800">
-                <a:solidFill>
-                  <a:srgbClr val="222222"/>
-                </a:solidFill>
-              </a:rPr>
-              <a:t>A project-owned driver records every artifact with provenance (reproducible, resumable).</a:t>
+              <a:rPr sz="2000">
+                <a:solidFill>
+                  <a:srgbClr val="1F1F1F"/>
+                </a:solidFill>
+              </a:rPr>
+              <a:t>• A project-owned driver records every artifact with provenance (reproducible, resumable).</a:t>
             </a:r>
           </a:p>
         </p:txBody>
@@ -3843,7 +4118,7 @@
         <p:spPr>
           <a:xfrm>
             <a:off x="457200" y="274320"/>
-            <a:ext cx="11274552" cy="914400"/>
+            <a:ext cx="11277295" cy="914400"/>
           </a:xfrm>
           <a:prstGeom prst="rect">
             <a:avLst/>
@@ -3857,7 +4132,7 @@
           <a:lstStyle/>
           <a:p>
             <a:r>
-              <a:rPr sz="3000" b="1">
+              <a:rPr sz="2800" b="1">
                 <a:solidFill>
                   <a:srgbClr val="002B5C"/>
                 </a:solidFill>
@@ -3869,14 +4144,58 @@
       </p:sp>
       <p:sp>
         <p:nvSpPr>
-          <p:cNvPr id="3" name="TextBox 2"/>
+          <p:cNvPr id="3" name="Rectangle 2"/>
+          <p:cNvSpPr/>
+          <p:nvPr/>
+        </p:nvSpPr>
+        <p:spPr>
+          <a:xfrm>
+            <a:off x="457200" y="1188720"/>
+            <a:ext cx="11277295" cy="54864"/>
+          </a:xfrm>
+          <a:prstGeom prst="rect">
+            <a:avLst/>
+          </a:prstGeom>
+          <a:solidFill>
+            <a:srgbClr val="007D8A"/>
+          </a:solidFill>
+          <a:ln>
+            <a:noFill/>
+          </a:ln>
+          <a:effectLst/>
+        </p:spPr>
+        <p:style>
+          <a:lnRef idx="1">
+            <a:schemeClr val="accent1"/>
+          </a:lnRef>
+          <a:fillRef idx="3">
+            <a:schemeClr val="accent1"/>
+          </a:fillRef>
+          <a:effectRef idx="2">
+            <a:schemeClr val="accent1"/>
+          </a:effectRef>
+          <a:fontRef idx="minor">
+            <a:schemeClr val="lt1"/>
+          </a:fontRef>
+        </p:style>
+        <p:txBody>
+          <a:bodyPr rtlCol="0" anchor="ctr"/>
+          <a:lstStyle/>
+          <a:p>
+            <a:pPr algn="ctr"/>
+          </a:p>
+        </p:txBody>
+      </p:sp>
+      <p:sp>
+        <p:nvSpPr>
+          <p:cNvPr id="4" name="TextBox 3"/>
           <p:cNvSpPr txBox="1"/>
           <p:nvPr/>
         </p:nvSpPr>
         <p:spPr>
           <a:xfrm>
-            <a:off x="640080" y="1371600"/>
-            <a:ext cx="6583680" cy="4937760"/>
+            <a:off x="548640" y="1463040"/>
+            <a:ext cx="10911535" cy="5029200"/>
           </a:xfrm>
           <a:prstGeom prst="rect">
             <a:avLst/>
@@ -3895,12 +4214,12 @@
               </a:spcAft>
             </a:pPr>
             <a:r>
-              <a:rPr sz="1800">
-                <a:solidFill>
-                  <a:srgbClr val="222222"/>
-                </a:solidFill>
-              </a:rPr>
-              <a:t>Prompt: “the Grad–Shafranov equilibrium for the plasma in a tokamak.”</a:t>
+              <a:rPr sz="2000">
+                <a:solidFill>
+                  <a:srgbClr val="1F1F1F"/>
+                </a:solidFill>
+              </a:rPr>
+              <a:t>• Prompt: “the Grad-Shafranov equilibrium for the plasma in a tokamak.”</a:t>
             </a:r>
           </a:p>
           <a:p>
@@ -3910,12 +4229,12 @@
               </a:spcAft>
             </a:pPr>
             <a:r>
-              <a:rPr sz="1800">
-                <a:solidFill>
-                  <a:srgbClr val="222222"/>
-                </a:solidFill>
-              </a:rPr>
-              <a:t>Modeling agent → identified 'Grad-Shafranov equation'; time-dependent = False.</a:t>
+              <a:rPr sz="2000">
+                <a:solidFill>
+                  <a:srgbClr val="1F1F1F"/>
+                </a:solidFill>
+              </a:rPr>
+              <a:t>• Modeling agent → identified 'Grad-Shafranov equation'; time-dependent = False.</a:t>
             </a:r>
           </a:p>
           <a:p>
@@ -3925,12 +4244,12 @@
               </a:spcAft>
             </a:pPr>
             <a:r>
-              <a:rPr sz="1800">
-                <a:solidFill>
-                  <a:srgbClr val="222222"/>
-                </a:solidFill>
-              </a:rPr>
-              <a:t>Numerical Analysis agent → nonlinear solve with SNES on a structured grid.</a:t>
+              <a:rPr sz="2000">
+                <a:solidFill>
+                  <a:srgbClr val="1F1F1F"/>
+                </a:solidFill>
+              </a:rPr>
+              <a:t>• Numerical Analysis agent → nonlinear solve with SNES on a structured grid.</a:t>
             </a:r>
           </a:p>
           <a:p>
@@ -3940,12 +4259,12 @@
               </a:spcAft>
             </a:pPr>
             <a:r>
-              <a:rPr sz="1800">
-                <a:solidFill>
-                  <a:srgbClr val="222222"/>
-                </a:solidFill>
-              </a:rPr>
-              <a:t>Code Generation agent → 267-line PETSc program (DMDA + SNES + true Jacobian).</a:t>
+              <a:rPr sz="2000">
+                <a:solidFill>
+                  <a:srgbClr val="1F1F1F"/>
+                </a:solidFill>
+              </a:rPr>
+              <a:t>• Code Generation agent → 267-line PETSc program (DMDA + SNES + true Jacobian).</a:t>
             </a:r>
           </a:p>
           <a:p>
@@ -3955,12 +4274,12 @@
               </a:spcAft>
             </a:pPr>
             <a:r>
-              <a:rPr sz="1800">
-                <a:solidFill>
-                  <a:srgbClr val="222222"/>
-                </a:solidFill>
-              </a:rPr>
-              <a:t>Compiled and ran on 1 and 4 MPI ranks with no human edits.</a:t>
+              <a:rPr sz="2000">
+                <a:solidFill>
+                  <a:srgbClr val="1F1F1F"/>
+                </a:solidFill>
+              </a:rPr>
+              <a:t>• Compiled and ran on 1 and 4 MPI ranks with no human edits.</a:t>
             </a:r>
           </a:p>
         </p:txBody>
@@ -3992,7 +4311,7 @@
         <p:spPr>
           <a:xfrm>
             <a:off x="457200" y="274320"/>
-            <a:ext cx="11274552" cy="914400"/>
+            <a:ext cx="11277295" cy="914400"/>
           </a:xfrm>
           <a:prstGeom prst="rect">
             <a:avLst/>
@@ -4006,7 +4325,7 @@
           <a:lstStyle/>
           <a:p>
             <a:r>
-              <a:rPr sz="3000" b="1">
+              <a:rPr sz="2800" b="1">
                 <a:solidFill>
                   <a:srgbClr val="002B5C"/>
                 </a:solidFill>
@@ -4018,14 +4337,58 @@
       </p:sp>
       <p:sp>
         <p:nvSpPr>
-          <p:cNvPr id="3" name="TextBox 2"/>
+          <p:cNvPr id="3" name="Rectangle 2"/>
+          <p:cNvSpPr/>
+          <p:nvPr/>
+        </p:nvSpPr>
+        <p:spPr>
+          <a:xfrm>
+            <a:off x="457200" y="1188720"/>
+            <a:ext cx="11277295" cy="54864"/>
+          </a:xfrm>
+          <a:prstGeom prst="rect">
+            <a:avLst/>
+          </a:prstGeom>
+          <a:solidFill>
+            <a:srgbClr val="007D8A"/>
+          </a:solidFill>
+          <a:ln>
+            <a:noFill/>
+          </a:ln>
+          <a:effectLst/>
+        </p:spPr>
+        <p:style>
+          <a:lnRef idx="1">
+            <a:schemeClr val="accent1"/>
+          </a:lnRef>
+          <a:fillRef idx="3">
+            <a:schemeClr val="accent1"/>
+          </a:fillRef>
+          <a:effectRef idx="2">
+            <a:schemeClr val="accent1"/>
+          </a:effectRef>
+          <a:fontRef idx="minor">
+            <a:schemeClr val="lt1"/>
+          </a:fontRef>
+        </p:style>
+        <p:txBody>
+          <a:bodyPr rtlCol="0" anchor="ctr"/>
+          <a:lstStyle/>
+          <a:p>
+            <a:pPr algn="ctr"/>
+          </a:p>
+        </p:txBody>
+      </p:sp>
+      <p:sp>
+        <p:nvSpPr>
+          <p:cNvPr id="4" name="TextBox 3"/>
           <p:cNvSpPr txBox="1"/>
           <p:nvPr/>
         </p:nvSpPr>
         <p:spPr>
           <a:xfrm>
-            <a:off x="548640" y="1371600"/>
-            <a:ext cx="10972800" cy="4114800"/>
+            <a:off x="548640" y="1463040"/>
+            <a:ext cx="10911535" cy="5029200"/>
           </a:xfrm>
           <a:prstGeom prst="rect">
             <a:avLst/>
@@ -4041,9 +4404,9 @@
             <a:r>
               <a:rPr sz="1400">
                 <a:solidFill>
-                  <a:srgbClr val="222222"/>
-                </a:solidFill>
-                <a:latin typeface="Courier New"/>
+                  <a:srgbClr val="1F1F1F"/>
+                </a:solidFill>
+                <a:latin typeface="Consolas"/>
               </a:rPr>
               <a:t>static PetscErrorCode FormFunction(SNES snes, Vec X, Vec F, void *ctx){</a:t>
             </a:r>
@@ -4052,31 +4415,42 @@
             <a:r>
               <a:rPr sz="1400">
                 <a:solidFill>
-                  <a:srgbClr val="222222"/>
-                </a:solidFill>
-                <a:latin typeface="Courier New"/>
-              </a:rPr>
-              <a:t>  /* Delta*_h psi = (psi_E-2psi_C+psi_W)/hR^2 - (1/R)(psi_E-psi_W)/(2hR)</a:t>
+                  <a:srgbClr val="1F1F1F"/>
+                </a:solidFill>
+                <a:latin typeface="Consolas"/>
+              </a:rPr>
+              <a:t>  /* Delta*_h psi = (psi_E-2psi_C+psi_W)/hR^2</a:t>
             </a:r>
           </a:p>
           <a:p>
             <a:r>
               <a:rPr sz="1400">
                 <a:solidFill>
-                  <a:srgbClr val="222222"/>
-                </a:solidFill>
-                <a:latin typeface="Courier New"/>
-              </a:rPr>
-              <a:t>                  + (psi_N-2psi_C+psi_S)/hZ^2                          */</a:t>
+                  <a:srgbClr val="1F1F1F"/>
+                </a:solidFill>
+                <a:latin typeface="Consolas"/>
+              </a:rPr>
+              <a:t>                  - (1/R)(psi_E-psi_W)/(2hR)</a:t>
             </a:r>
           </a:p>
           <a:p>
             <a:r>
               <a:rPr sz="1400">
                 <a:solidFill>
-                  <a:srgbClr val="222222"/>
-                </a:solidFill>
-                <a:latin typeface="Courier New"/>
+                  <a:srgbClr val="1F1F1F"/>
+                </a:solidFill>
+                <a:latin typeface="Consolas"/>
+              </a:rPr>
+              <a:t>                  + (psi_N-2psi_C+psi_S)/hZ^2   */</a:t>
+            </a:r>
+          </a:p>
+          <a:p>
+            <a:r>
+              <a:rPr sz="1400">
+                <a:solidFill>
+                  <a:srgbClr val="1F1F1F"/>
+                </a:solidFill>
+                <a:latin typeface="Consolas"/>
               </a:rPr>
               <a:t>  f[j][i] = dRR - dR1/R + dZZ - ForcingF(user,R,Z);   /* residual */</a:t>
             </a:r>
@@ -4085,9 +4459,9 @@
             <a:r>
               <a:rPr sz="1400">
                 <a:solidFill>
-                  <a:srgbClr val="222222"/>
-                </a:solidFill>
-                <a:latin typeface="Courier New"/>
+                  <a:srgbClr val="1F1F1F"/>
+                </a:solidFill>
+                <a:latin typeface="Consolas"/>
               </a:rPr>
               <a:t>}</a:t>
             </a:r>
@@ -4096,9 +4470,9 @@
             <a:r>
               <a:rPr sz="1400">
                 <a:solidFill>
-                  <a:srgbClr val="222222"/>
-                </a:solidFill>
-                <a:latin typeface="Courier New"/>
+                  <a:srgbClr val="1F1F1F"/>
+                </a:solidFill>
+                <a:latin typeface="Consolas"/>
               </a:rPr>
               <a:t>SNESSetFunction(snes, r, FormFunction, &amp;user);</a:t>
             </a:r>
@@ -4107,9 +4481,9 @@
             <a:r>
               <a:rPr sz="1400">
                 <a:solidFill>
-                  <a:srgbClr val="222222"/>
-                </a:solidFill>
-                <a:latin typeface="Courier New"/>
+                  <a:srgbClr val="1F1F1F"/>
+                </a:solidFill>
+                <a:latin typeface="Consolas"/>
               </a:rPr>
               <a:t>SNESSetJacobian(snes, J, J, FormJacobian, &amp;user);   /* true Jacobian */</a:t>
             </a:r>
@@ -4118,9 +4492,9 @@
             <a:r>
               <a:rPr sz="1400">
                 <a:solidFill>
-                  <a:srgbClr val="222222"/>
-                </a:solidFill>
-                <a:latin typeface="Courier New"/>
+                  <a:srgbClr val="1F1F1F"/>
+                </a:solidFill>
+                <a:latin typeface="Consolas"/>
               </a:rPr>
               <a:t>SNESSolve(snes, NULL, x);</a:t>
             </a:r>
@@ -4154,7 +4528,7 @@
         <p:spPr>
           <a:xfrm>
             <a:off x="457200" y="274320"/>
-            <a:ext cx="11274552" cy="914400"/>
+            <a:ext cx="11277295" cy="914400"/>
           </a:xfrm>
           <a:prstGeom prst="rect">
             <a:avLst/>
@@ -4168,7 +4542,7 @@
           <a:lstStyle/>
           <a:p>
             <a:r>
-              <a:rPr sz="3000" b="1">
+              <a:rPr sz="2800" b="1">
                 <a:solidFill>
                   <a:srgbClr val="002B5C"/>
                 </a:solidFill>
@@ -4180,14 +4554,58 @@
       </p:sp>
       <p:sp>
         <p:nvSpPr>
-          <p:cNvPr id="3" name="TextBox 2"/>
+          <p:cNvPr id="3" name="Rectangle 2"/>
+          <p:cNvSpPr/>
+          <p:nvPr/>
+        </p:nvSpPr>
+        <p:spPr>
+          <a:xfrm>
+            <a:off x="457200" y="1188720"/>
+            <a:ext cx="11277295" cy="54864"/>
+          </a:xfrm>
+          <a:prstGeom prst="rect">
+            <a:avLst/>
+          </a:prstGeom>
+          <a:solidFill>
+            <a:srgbClr val="007D8A"/>
+          </a:solidFill>
+          <a:ln>
+            <a:noFill/>
+          </a:ln>
+          <a:effectLst/>
+        </p:spPr>
+        <p:style>
+          <a:lnRef idx="1">
+            <a:schemeClr val="accent1"/>
+          </a:lnRef>
+          <a:fillRef idx="3">
+            <a:schemeClr val="accent1"/>
+          </a:fillRef>
+          <a:effectRef idx="2">
+            <a:schemeClr val="accent1"/>
+          </a:effectRef>
+          <a:fontRef idx="minor">
+            <a:schemeClr val="lt1"/>
+          </a:fontRef>
+        </p:style>
+        <p:txBody>
+          <a:bodyPr rtlCol="0" anchor="ctr"/>
+          <a:lstStyle/>
+          <a:p>
+            <a:pPr algn="ctr"/>
+          </a:p>
+        </p:txBody>
+      </p:sp>
+      <p:sp>
+        <p:nvSpPr>
+          <p:cNvPr id="4" name="TextBox 3"/>
           <p:cNvSpPr txBox="1"/>
           <p:nvPr/>
         </p:nvSpPr>
         <p:spPr>
           <a:xfrm>
-            <a:off x="640080" y="1371600"/>
-            <a:ext cx="6035040" cy="4937760"/>
+            <a:off x="548640" y="1463040"/>
+            <a:ext cx="5852160" cy="5029200"/>
           </a:xfrm>
           <a:prstGeom prst="rect">
             <a:avLst/>
@@ -4206,12 +4624,12 @@
               </a:spcAft>
             </a:pPr>
             <a:r>
-              <a:rPr sz="1800">
-                <a:solidFill>
-                  <a:srgbClr val="222222"/>
-                </a:solidFill>
-              </a:rPr>
-              <a:t>Method of manufactured solutions: known exact ψ, check the numerical error.</a:t>
+              <a:rPr sz="2000">
+                <a:solidFill>
+                  <a:srgbClr val="1F1F1F"/>
+                </a:solidFill>
+              </a:rPr>
+              <a:t>• Method of manufactured solutions: known exact psi, check the numerical error.</a:t>
             </a:r>
           </a:p>
           <a:p>
@@ -4221,12 +4639,12 @@
               </a:spcAft>
             </a:pPr>
             <a:r>
-              <a:rPr sz="1800">
-                <a:solidFill>
-                  <a:srgbClr val="222222"/>
-                </a:solidFill>
-              </a:rPr>
-              <a:t>Max-norm error = 1.32e-05 on 65×65.</a:t>
+              <a:rPr sz="2000">
+                <a:solidFill>
+                  <a:srgbClr val="1F1F1F"/>
+                </a:solidFill>
+              </a:rPr>
+              <a:t>• Max-norm error = 1.32e-05 on 65x65.</a:t>
             </a:r>
           </a:p>
           <a:p>
@@ -4236,12 +4654,12 @@
               </a:spcAft>
             </a:pPr>
             <a:r>
-              <a:rPr sz="1800">
-                <a:solidFill>
-                  <a:srgbClr val="222222"/>
-                </a:solidFill>
-              </a:rPr>
-              <a:t>Observed order of accuracy p = 2.00, 2.00, 2.00 (expected 2 for central differences).</a:t>
+              <a:rPr sz="2000">
+                <a:solidFill>
+                  <a:srgbClr val="1F1F1F"/>
+                </a:solidFill>
+              </a:rPr>
+              <a:t>• Observed order of accuracy p = 2.00, 2.00, 2.00 (expected 2 for central differences).</a:t>
             </a:r>
           </a:p>
           <a:p>
@@ -4251,19 +4669,19 @@
               </a:spcAft>
             </a:pPr>
             <a:r>
-              <a:rPr sz="1800">
-                <a:solidFill>
-                  <a:srgbClr val="222222"/>
-                </a:solidFill>
-              </a:rPr>
-              <a:t>SNES: SNESConvergedReason   : CONVERGED_FNORM_RELATIVE.</a:t>
+              <a:rPr sz="2000">
+                <a:solidFill>
+                  <a:srgbClr val="1F1F1F"/>
+                </a:solidFill>
+              </a:rPr>
+              <a:t>• SNES: CONVERGED_FNORM_RELATIVE.</a:t>
             </a:r>
           </a:p>
         </p:txBody>
       </p:sp>
       <p:pic>
         <p:nvPicPr>
-          <p:cNvPr id="4" name="Picture 3" descr="gs_convergence.png"/>
+          <p:cNvPr id="5" name="Picture 4" descr="gs_convergence.png"/>
           <p:cNvPicPr>
             <a:picLocks noChangeAspect="1"/>
           </p:cNvPicPr>
@@ -4277,14 +4695,48 @@
         </p:blipFill>
         <p:spPr>
           <a:xfrm>
-            <a:off x="6766560" y="1463040"/>
-            <a:ext cx="5029200" cy="3771900"/>
+            <a:off x="7223760" y="1554480"/>
+            <a:ext cx="4510735" cy="3383051"/>
           </a:xfrm>
           <a:prstGeom prst="rect">
             <a:avLst/>
           </a:prstGeom>
         </p:spPr>
       </p:pic>
+      <p:sp>
+        <p:nvSpPr>
+          <p:cNvPr id="6" name="TextBox 5"/>
+          <p:cNvSpPr txBox="1"/>
+          <p:nvPr/>
+        </p:nvSpPr>
+        <p:spPr>
+          <a:xfrm>
+            <a:off x="7223760" y="4983251"/>
+            <a:ext cx="4510735" cy="457200"/>
+          </a:xfrm>
+          <a:prstGeom prst="rect">
+            <a:avLst/>
+          </a:prstGeom>
+          <a:noFill/>
+        </p:spPr>
+        <p:txBody>
+          <a:bodyPr wrap="none">
+            <a:spAutoFit/>
+          </a:bodyPr>
+          <a:lstStyle/>
+          <a:p>
+            <a:pPr algn="ctr"/>
+            <a:r>
+              <a:rPr sz="1300">
+                <a:solidFill>
+                  <a:srgbClr val="4A4A4A"/>
+                </a:solidFill>
+              </a:rPr>
+              <a:t>Manufactured-solution convergence</a:t>
+            </a:r>
+          </a:p>
+        </p:txBody>
+      </p:sp>
     </p:spTree>
   </p:cSld>
   <p:clrMapOvr>
@@ -4312,7 +4764,7 @@
         <p:spPr>
           <a:xfrm>
             <a:off x="457200" y="274320"/>
-            <a:ext cx="11274552" cy="914400"/>
+            <a:ext cx="11277295" cy="914400"/>
           </a:xfrm>
           <a:prstGeom prst="rect">
             <a:avLst/>
@@ -4326,7 +4778,7 @@
           <a:lstStyle/>
           <a:p>
             <a:r>
-              <a:rPr sz="3000" b="1">
+              <a:rPr sz="2800" b="1">
                 <a:solidFill>
                   <a:srgbClr val="002B5C"/>
                 </a:solidFill>
@@ -4338,14 +4790,58 @@
       </p:sp>
       <p:sp>
         <p:nvSpPr>
-          <p:cNvPr id="3" name="TextBox 2"/>
+          <p:cNvPr id="3" name="Rectangle 2"/>
+          <p:cNvSpPr/>
+          <p:nvPr/>
+        </p:nvSpPr>
+        <p:spPr>
+          <a:xfrm>
+            <a:off x="457200" y="1188720"/>
+            <a:ext cx="11277295" cy="54864"/>
+          </a:xfrm>
+          <a:prstGeom prst="rect">
+            <a:avLst/>
+          </a:prstGeom>
+          <a:solidFill>
+            <a:srgbClr val="007D8A"/>
+          </a:solidFill>
+          <a:ln>
+            <a:noFill/>
+          </a:ln>
+          <a:effectLst/>
+        </p:spPr>
+        <p:style>
+          <a:lnRef idx="1">
+            <a:schemeClr val="accent1"/>
+          </a:lnRef>
+          <a:fillRef idx="3">
+            <a:schemeClr val="accent1"/>
+          </a:fillRef>
+          <a:effectRef idx="2">
+            <a:schemeClr val="accent1"/>
+          </a:effectRef>
+          <a:fontRef idx="minor">
+            <a:schemeClr val="lt1"/>
+          </a:fontRef>
+        </p:style>
+        <p:txBody>
+          <a:bodyPr rtlCol="0" anchor="ctr"/>
+          <a:lstStyle/>
+          <a:p>
+            <a:pPr algn="ctr"/>
+          </a:p>
+        </p:txBody>
+      </p:sp>
+      <p:sp>
+        <p:nvSpPr>
+          <p:cNvPr id="4" name="TextBox 3"/>
           <p:cNvSpPr txBox="1"/>
           <p:nvPr/>
         </p:nvSpPr>
         <p:spPr>
           <a:xfrm>
-            <a:off x="640080" y="1371600"/>
-            <a:ext cx="6583680" cy="4937760"/>
+            <a:off x="548640" y="1463040"/>
+            <a:ext cx="10911535" cy="5029200"/>
           </a:xfrm>
           <a:prstGeom prst="rect">
             <a:avLst/>
@@ -4364,12 +4860,12 @@
               </a:spcAft>
             </a:pPr>
             <a:r>
-              <a:rPr sz="1800">
-                <a:solidFill>
-                  <a:srgbClr val="222222"/>
-                </a:solidFill>
-              </a:rPr>
-              <a:t>Correctness: model identified ✓, compiled &amp; ran ✓, 2nd-order convergence ✓.</a:t>
+              <a:rPr sz="2000">
+                <a:solidFill>
+                  <a:srgbClr val="1F1F1F"/>
+                </a:solidFill>
+              </a:rPr>
+              <a:t>• Correctness: model identified ✓, compiled &amp; ran ✓, 2nd-order convergence ✓.</a:t>
             </a:r>
           </a:p>
           <a:p>
@@ -4379,12 +4875,12 @@
               </a:spcAft>
             </a:pPr>
             <a:r>
-              <a:rPr sz="1800">
-                <a:solidFill>
-                  <a:srgbClr val="222222"/>
-                </a:solidFill>
-              </a:rPr>
-              <a:t>Human effort: 0 lines of solver code hand-written (it was generated).</a:t>
+              <a:rPr sz="2000">
+                <a:solidFill>
+                  <a:srgbClr val="1F1F1F"/>
+                </a:solidFill>
+              </a:rPr>
+              <a:t>• Human effort: 0 lines of solver code hand-written (it was generated).</a:t>
             </a:r>
           </a:p>
           <a:p>
@@ -4394,12 +4890,12 @@
               </a:spcAft>
             </a:pPr>
             <a:r>
-              <a:rPr sz="1800">
-                <a:solidFill>
-                  <a:srgbClr val="222222"/>
-                </a:solidFill>
-              </a:rPr>
-              <a:t>Efficiency: total wall-clock ≈ 450.8 s; code-gen used 5 tool calls.</a:t>
+              <a:rPr sz="2000">
+                <a:solidFill>
+                  <a:srgbClr val="1F1F1F"/>
+                </a:solidFill>
+              </a:rPr>
+              <a:t>• Efficiency: total wall-clock ≈ 450.8 s; code-gen used 5 tool calls.</a:t>
             </a:r>
           </a:p>
           <a:p>
@@ -4409,12 +4905,12 @@
               </a:spcAft>
             </a:pPr>
             <a:r>
-              <a:rPr sz="1800">
-                <a:solidFill>
-                  <a:srgbClr val="222222"/>
-                </a:solidFill>
-              </a:rPr>
-              <a:t>Approx. 23 LLM completions across the whole pipeline.</a:t>
+              <a:rPr sz="2000">
+                <a:solidFill>
+                  <a:srgbClr val="1F1F1F"/>
+                </a:solidFill>
+              </a:rPr>
+              <a:t>• Approx. 23 LLM completions across the whole pipeline.</a:t>
             </a:r>
           </a:p>
         </p:txBody>
@@ -4446,7 +4942,7 @@
         <p:spPr>
           <a:xfrm>
             <a:off x="457200" y="274320"/>
-            <a:ext cx="11274552" cy="914400"/>
+            <a:ext cx="11277295" cy="914400"/>
           </a:xfrm>
           <a:prstGeom prst="rect">
             <a:avLst/>
@@ -4460,7 +4956,7 @@
           <a:lstStyle/>
           <a:p>
             <a:r>
-              <a:rPr sz="3000" b="1">
+              <a:rPr sz="2800" b="1">
                 <a:solidFill>
                   <a:srgbClr val="002B5C"/>
                 </a:solidFill>
@@ -4472,14 +4968,58 @@
       </p:sp>
       <p:sp>
         <p:nvSpPr>
-          <p:cNvPr id="3" name="TextBox 2"/>
+          <p:cNvPr id="3" name="Rectangle 2"/>
+          <p:cNvSpPr/>
+          <p:nvPr/>
+        </p:nvSpPr>
+        <p:spPr>
+          <a:xfrm>
+            <a:off x="457200" y="1188720"/>
+            <a:ext cx="11277295" cy="54864"/>
+          </a:xfrm>
+          <a:prstGeom prst="rect">
+            <a:avLst/>
+          </a:prstGeom>
+          <a:solidFill>
+            <a:srgbClr val="007D8A"/>
+          </a:solidFill>
+          <a:ln>
+            <a:noFill/>
+          </a:ln>
+          <a:effectLst/>
+        </p:spPr>
+        <p:style>
+          <a:lnRef idx="1">
+            <a:schemeClr val="accent1"/>
+          </a:lnRef>
+          <a:fillRef idx="3">
+            <a:schemeClr val="accent1"/>
+          </a:fillRef>
+          <a:effectRef idx="2">
+            <a:schemeClr val="accent1"/>
+          </a:effectRef>
+          <a:fontRef idx="minor">
+            <a:schemeClr val="lt1"/>
+          </a:fontRef>
+        </p:style>
+        <p:txBody>
+          <a:bodyPr rtlCol="0" anchor="ctr"/>
+          <a:lstStyle/>
+          <a:p>
+            <a:pPr algn="ctr"/>
+          </a:p>
+        </p:txBody>
+      </p:sp>
+      <p:sp>
+        <p:nvSpPr>
+          <p:cNvPr id="4" name="TextBox 3"/>
           <p:cNvSpPr txBox="1"/>
           <p:nvPr/>
         </p:nvSpPr>
         <p:spPr>
           <a:xfrm>
-            <a:off x="640080" y="1371600"/>
-            <a:ext cx="6583680" cy="4937760"/>
+            <a:off x="548640" y="1463040"/>
+            <a:ext cx="10911535" cy="5029200"/>
           </a:xfrm>
           <a:prstGeom prst="rect">
             <a:avLst/>
@@ -4498,12 +5038,12 @@
               </a:spcAft>
             </a:pPr>
             <a:r>
-              <a:rPr sz="1800">
-                <a:solidFill>
-                  <a:srgbClr val="222222"/>
-                </a:solidFill>
-              </a:rPr>
-              <a:t>A project-owned orchestration driver with full artifact provenance (resumable).</a:t>
+              <a:rPr sz="2000">
+                <a:solidFill>
+                  <a:srgbClr val="1F1F1F"/>
+                </a:solidFill>
+              </a:rPr>
+              <a:t>• A project-owned orchestration driver with full artifact provenance (resumable).</a:t>
             </a:r>
           </a:p>
           <a:p>
@@ -4513,12 +5053,12 @@
               </a:spcAft>
             </a:pPr>
             <a:r>
-              <a:rPr sz="1800">
-                <a:solidFill>
-                  <a:srgbClr val="222222"/>
-                </a:solidFill>
-              </a:rPr>
-              <a:t>Verification + post-processing (convergence, flux surfaces) and a metrics harness.</a:t>
+              <a:rPr sz="2000">
+                <a:solidFill>
+                  <a:srgbClr val="1F1F1F"/>
+                </a:solidFill>
+              </a:rPr>
+              <a:t>• Verification + post-processing (convergence, flux surfaces) and a metrics harness.</a:t>
             </a:r>
           </a:p>
           <a:p>
@@ -4528,12 +5068,12 @@
               </a:spcAft>
             </a:pPr>
             <a:r>
-              <a:rPr sz="1800">
-                <a:solidFill>
-                  <a:srgbClr val="222222"/>
-                </a:solidFill>
-              </a:rPr>
-              <a:t>Fixes contributed back to the open multi-agent system:</a:t>
+              <a:rPr sz="2000">
+                <a:solidFill>
+                  <a:srgbClr val="1F1F1F"/>
+                </a:solidFill>
+              </a:rPr>
+              <a:t>• Fixes contributed back to the open multi-agent system:</a:t>
             </a:r>
           </a:p>
           <a:p>
@@ -4543,12 +5083,12 @@
               </a:spcAft>
             </a:pPr>
             <a:r>
-              <a:rPr sz="1500">
-                <a:solidFill>
-                  <a:srgbClr val="555555"/>
-                </a:solidFill>
-              </a:rPr>
-              <a:t>CWD-independent server resolution (absolute paths)</a:t>
+              <a:rPr sz="1700">
+                <a:solidFill>
+                  <a:srgbClr val="4A4A4A"/>
+                </a:solidFill>
+              </a:rPr>
+              <a:t>– CWD-independent server resolution (absolute paths)</a:t>
             </a:r>
           </a:p>
           <a:p>
@@ -4558,12 +5098,12 @@
               </a:spcAft>
             </a:pPr>
             <a:r>
-              <a:rPr sz="1500">
-                <a:solidFill>
-                  <a:srgbClr val="555555"/>
-                </a:solidFill>
-              </a:rPr>
-              <a:t>graceful operation without the documentation/RAG services</a:t>
+              <a:rPr sz="1700">
+                <a:solidFill>
+                  <a:srgbClr val="4A4A4A"/>
+                </a:solidFill>
+              </a:rPr>
+              <a:t>– graceful operation without the documentation/RAG services</a:t>
             </a:r>
           </a:p>
           <a:p>
@@ -4573,12 +5113,12 @@
               </a:spcAft>
             </a:pPr>
             <a:r>
-              <a:rPr sz="1500">
-                <a:solidFill>
-                  <a:srgbClr val="555555"/>
-                </a:solidFill>
-              </a:rPr>
-              <a:t>a code-generation loop that reliably captures results</a:t>
+              <a:rPr sz="1700">
+                <a:solidFill>
+                  <a:srgbClr val="4A4A4A"/>
+                </a:solidFill>
+              </a:rPr>
+              <a:t>– a code-generation loop that reliably captures results</a:t>
             </a:r>
           </a:p>
         </p:txBody>

</xml_diff>